<commit_message>
Fix misleading forecast-error framing in the next-steps section
The docx and slide deck implied the study never tested imperfect
forecasts. It did (Gaussian noise, 4 levels, across all 84 runs) -- the
real gap is synthetic independent noise vs. a live feed's correlated,
biased error.

Co-Authored-By: Claude Sonnet 5 <noreply@anthropic.com>
</commit_message>
<xml_diff>
--- a/SOTA_Commission_II_Slides.pptx
+++ b/SOTA_Commission_II_Slides.pptx
@@ -6528,7 +6528,7 @@
                 </a:solidFill>
                 <a:latin typeface="Cambria"/>
               </a:rPr>
-              <a:t>From perfect hindsight to a live decision framework</a:t>
+              <a:t>From simulated forecast error to a live decision framework</a:t>
             </a:r>
           </a:p>
         </p:txBody>
@@ -6581,7 +6581,7 @@
                 </a:solidFill>
                 <a:latin typeface="Calibri"/>
               </a:rPr>
-              <a:t>Replace this study's perfect-hindsight forecast with a live weather feed.</a:t>
+              <a:t>All 84 runs already cover imperfect forecasts, but as synthetic, independent Gaussian noise. Swap in a live weather feed, whose errors are time-correlated and often biased in ways white noise isn't, and see if the same strategy rankings hold.</a:t>
             </a:r>
           </a:p>
           <a:p>

</xml_diff>

<commit_message>
Fix slide 3's architecture diagram: it showed the wrong power routing
The old diagram implied the battery feeds the electrolyzer/DAC too.
It never does -- only the reactor gets battery access, which is the
whole point of the "what failed" slide. Redrawn as two separate power
paths (PV to industrial loads; PV/battery to the reactor) and cleaned
up overlapping labels.

Co-Authored-By: Claude Sonnet 5 <noreply@anthropic.com>
</commit_message>
<xml_diff>
--- a/SOTA_Commission_II_Slides.pptx
+++ b/SOTA_Commission_II_Slides.pptx
@@ -3864,7 +3864,7 @@
         <p:spPr>
           <a:xfrm>
             <a:off x="640080" y="1874519"/>
-            <a:ext cx="1554480" cy="685800"/>
+            <a:ext cx="1965960" cy="566928"/>
           </a:xfrm>
           <a:prstGeom prst="roundRect">
             <a:avLst>
@@ -3912,20 +3912,22 @@
       </p:sp>
       <p:sp>
         <p:nvSpPr>
-          <p:cNvPr id="5" name="Right Arrow 4"/>
+          <p:cNvPr id="5" name="Rounded Rectangle 4"/>
           <p:cNvSpPr/>
           <p:nvPr/>
         </p:nvSpPr>
         <p:spPr>
           <a:xfrm>
-            <a:off x="2194560" y="2089403"/>
-            <a:ext cx="320040" cy="256032"/>
-          </a:xfrm>
-          <a:prstGeom prst="rightArrow">
-            <a:avLst/>
+            <a:off x="3383280" y="1874519"/>
+            <a:ext cx="1965960" cy="566928"/>
+          </a:xfrm>
+          <a:prstGeom prst="roundRect">
+            <a:avLst>
+              <a:gd name="adj" fmla="val 12000"/>
+            </a:avLst>
           </a:prstGeom>
           <a:solidFill>
-            <a:srgbClr val="9AA1AC"/>
+            <a:srgbClr val="F4F6F8"/>
           </a:solidFill>
           <a:ln>
             <a:noFill/>
@@ -3947,31 +3949,39 @@
           </a:fontRef>
         </p:style>
         <p:txBody>
-          <a:bodyPr rtlCol="0" anchor="ctr"/>
+          <a:bodyPr rtlCol="0" anchor="ctr" wrap="square" lIns="50800" rIns="50800"/>
           <a:lstStyle/>
           <a:p>
             <a:pPr algn="ctr"/>
-          </a:p>
-        </p:txBody>
-      </p:sp>
-      <p:sp>
-        <p:nvSpPr>
-          <p:cNvPr id="6" name="Rounded Rectangle 5"/>
+            <a:r>
+              <a:rPr sz="1150" b="1">
+                <a:solidFill>
+                  <a:srgbClr val="1A1A1A"/>
+                </a:solidFill>
+                <a:latin typeface="Calibri"/>
+              </a:rPr>
+              <a:t>Electrolyzer
++ DAC</a:t>
+            </a:r>
+          </a:p>
+        </p:txBody>
+      </p:sp>
+      <p:sp>
+        <p:nvSpPr>
+          <p:cNvPr id="6" name="Right Arrow 5"/>
           <p:cNvSpPr/>
           <p:nvPr/>
         </p:nvSpPr>
         <p:spPr>
           <a:xfrm>
-            <a:off x="2514600" y="1874519"/>
-            <a:ext cx="1554480" cy="685800"/>
-          </a:xfrm>
-          <a:prstGeom prst="roundRect">
-            <a:avLst>
-              <a:gd name="adj" fmla="val 12000"/>
-            </a:avLst>
+            <a:off x="2679192" y="2048255"/>
+            <a:ext cx="630936" cy="219456"/>
+          </a:xfrm>
+          <a:prstGeom prst="rightArrow">
+            <a:avLst/>
           </a:prstGeom>
           <a:solidFill>
-            <a:srgbClr val="1E2761"/>
+            <a:srgbClr val="9AA1AC"/>
           </a:solidFill>
           <a:ln>
             <a:noFill/>
@@ -3993,39 +4003,73 @@
           </a:fontRef>
         </p:style>
         <p:txBody>
-          <a:bodyPr rtlCol="0" anchor="ctr" wrap="square" lIns="50800" rIns="50800"/>
+          <a:bodyPr rtlCol="0" anchor="ctr"/>
           <a:lstStyle/>
           <a:p>
             <a:pPr algn="ctr"/>
-            <a:r>
-              <a:rPr sz="1250" b="1">
-                <a:solidFill>
-                  <a:srgbClr val="FFFFFF"/>
+          </a:p>
+        </p:txBody>
+      </p:sp>
+      <p:sp>
+        <p:nvSpPr>
+          <p:cNvPr id="7" name="TextBox 6"/>
+          <p:cNvSpPr txBox="1"/>
+          <p:nvPr/>
+        </p:nvSpPr>
+        <p:spPr>
+          <a:xfrm>
+            <a:off x="2679192" y="2258567"/>
+            <a:ext cx="630936" cy="201168"/>
+          </a:xfrm>
+          <a:prstGeom prst="rect">
+            <a:avLst/>
+          </a:prstGeom>
+          <a:noFill/>
+        </p:spPr>
+        <p:txBody>
+          <a:bodyPr wrap="square" anchor="t" lIns="0" rIns="0" tIns="0" bIns="0">
+            <a:spAutoFit/>
+          </a:bodyPr>
+          <a:lstStyle/>
+          <a:p>
+            <a:pPr algn="ctr">
+              <a:lnSpc>
+                <a:spcPct val="115000"/>
+              </a:lnSpc>
+              <a:spcAft>
+                <a:spcPts val="0"/>
+              </a:spcAft>
+            </a:pPr>
+            <a:r>
+              <a:rPr sz="850" b="0" i="1">
+                <a:solidFill>
+                  <a:srgbClr val="5B6372"/>
                 </a:solidFill>
                 <a:latin typeface="Calibri"/>
               </a:rPr>
-              <a:t>Battery
-(BESS)</a:t>
-            </a:r>
-          </a:p>
-        </p:txBody>
-      </p:sp>
-      <p:sp>
-        <p:nvSpPr>
-          <p:cNvPr id="7" name="Right Arrow 6"/>
+              <a:t>PV surplus only</a:t>
+            </a:r>
+          </a:p>
+        </p:txBody>
+      </p:sp>
+      <p:sp>
+        <p:nvSpPr>
+          <p:cNvPr id="8" name="Rounded Rectangle 7"/>
           <p:cNvSpPr/>
           <p:nvPr/>
         </p:nvSpPr>
         <p:spPr>
           <a:xfrm>
-            <a:off x="4069080" y="2089403"/>
-            <a:ext cx="320040" cy="256032"/>
-          </a:xfrm>
-          <a:prstGeom prst="rightArrow">
-            <a:avLst/>
+            <a:off x="640080" y="3044951"/>
+            <a:ext cx="1965960" cy="566928"/>
+          </a:xfrm>
+          <a:prstGeom prst="roundRect">
+            <a:avLst>
+              <a:gd name="adj" fmla="val 12000"/>
+            </a:avLst>
           </a:prstGeom>
           <a:solidFill>
-            <a:srgbClr val="9AA1AC"/>
+            <a:srgbClr val="1E2761"/>
           </a:solidFill>
           <a:ln>
             <a:noFill/>
@@ -4047,23 +4091,33 @@
           </a:fontRef>
         </p:style>
         <p:txBody>
-          <a:bodyPr rtlCol="0" anchor="ctr"/>
+          <a:bodyPr rtlCol="0" anchor="ctr" wrap="square" lIns="50800" rIns="50800"/>
           <a:lstStyle/>
           <a:p>
             <a:pPr algn="ctr"/>
-          </a:p>
-        </p:txBody>
-      </p:sp>
-      <p:sp>
-        <p:nvSpPr>
-          <p:cNvPr id="8" name="Rounded Rectangle 7"/>
+            <a:r>
+              <a:rPr sz="1250" b="1">
+                <a:solidFill>
+                  <a:srgbClr val="FFFFFF"/>
+                </a:solidFill>
+                <a:latin typeface="Calibri"/>
+              </a:rPr>
+              <a:t>Battery
+(BESS)</a:t>
+            </a:r>
+          </a:p>
+        </p:txBody>
+      </p:sp>
+      <p:sp>
+        <p:nvSpPr>
+          <p:cNvPr id="9" name="Rounded Rectangle 8"/>
           <p:cNvSpPr/>
           <p:nvPr/>
         </p:nvSpPr>
         <p:spPr>
           <a:xfrm>
-            <a:off x="4389120" y="1874519"/>
-            <a:ext cx="1828800" cy="384048"/>
+            <a:off x="3383280" y="3044951"/>
+            <a:ext cx="1965960" cy="566928"/>
           </a:xfrm>
           <a:prstGeom prst="roundRect">
             <a:avLst>
@@ -4071,7 +4125,7 @@
             </a:avLst>
           </a:prstGeom>
           <a:solidFill>
-            <a:srgbClr val="F4F6F8"/>
+            <a:srgbClr val="FCE4E4"/>
           </a:solidFill>
           <a:ln>
             <a:noFill/>
@@ -4098,35 +4152,33 @@
           <a:p>
             <a:pPr algn="ctr"/>
             <a:r>
-              <a:rPr sz="1100" b="1">
-                <a:solidFill>
-                  <a:srgbClr val="1A1A1A"/>
+              <a:rPr sz="1150" b="1">
+                <a:solidFill>
+                  <a:srgbClr val="9A2A2A"/>
                 </a:solidFill>
                 <a:latin typeface="Calibri"/>
               </a:rPr>
-              <a:t>Electrolyzer</a:t>
-            </a:r>
-          </a:p>
-        </p:txBody>
-      </p:sp>
-      <p:sp>
-        <p:nvSpPr>
-          <p:cNvPr id="9" name="Rounded Rectangle 8"/>
+              <a:t>Sabatier reactor</a:t>
+            </a:r>
+          </a:p>
+        </p:txBody>
+      </p:sp>
+      <p:sp>
+        <p:nvSpPr>
+          <p:cNvPr id="10" name="Right Arrow 9"/>
           <p:cNvSpPr/>
           <p:nvPr/>
         </p:nvSpPr>
         <p:spPr>
           <a:xfrm>
-            <a:off x="4389120" y="2322575"/>
-            <a:ext cx="1828800" cy="384048"/>
-          </a:xfrm>
-          <a:prstGeom prst="roundRect">
-            <a:avLst>
-              <a:gd name="adj" fmla="val 12000"/>
-            </a:avLst>
+            <a:off x="2679192" y="3218687"/>
+            <a:ext cx="630936" cy="219456"/>
+          </a:xfrm>
+          <a:prstGeom prst="rightArrow">
+            <a:avLst/>
           </a:prstGeom>
           <a:solidFill>
-            <a:srgbClr val="F4F6F8"/>
+            <a:srgbClr val="9AA1AC"/>
           </a:solidFill>
           <a:ln>
             <a:noFill/>
@@ -4148,40 +4200,71 @@
           </a:fontRef>
         </p:style>
         <p:txBody>
-          <a:bodyPr rtlCol="0" anchor="ctr" wrap="square" lIns="50800" rIns="50800"/>
+          <a:bodyPr rtlCol="0" anchor="ctr"/>
           <a:lstStyle/>
           <a:p>
             <a:pPr algn="ctr"/>
-            <a:r>
-              <a:rPr sz="1100" b="1">
-                <a:solidFill>
-                  <a:srgbClr val="1A1A1A"/>
+          </a:p>
+        </p:txBody>
+      </p:sp>
+      <p:sp>
+        <p:nvSpPr>
+          <p:cNvPr id="11" name="TextBox 10"/>
+          <p:cNvSpPr txBox="1"/>
+          <p:nvPr/>
+        </p:nvSpPr>
+        <p:spPr>
+          <a:xfrm>
+            <a:off x="2679192" y="3428999"/>
+            <a:ext cx="630936" cy="201168"/>
+          </a:xfrm>
+          <a:prstGeom prst="rect">
+            <a:avLst/>
+          </a:prstGeom>
+          <a:noFill/>
+        </p:spPr>
+        <p:txBody>
+          <a:bodyPr wrap="square" anchor="t" lIns="0" rIns="0" tIns="0" bIns="0">
+            <a:spAutoFit/>
+          </a:bodyPr>
+          <a:lstStyle/>
+          <a:p>
+            <a:pPr algn="ctr">
+              <a:lnSpc>
+                <a:spcPct val="115000"/>
+              </a:lnSpc>
+              <a:spcAft>
+                <a:spcPts val="0"/>
+              </a:spcAft>
+            </a:pPr>
+            <a:r>
+              <a:rPr sz="850" b="0" i="1">
+                <a:solidFill>
+                  <a:srgbClr val="5B6372"/>
                 </a:solidFill>
                 <a:latin typeface="Calibri"/>
               </a:rPr>
-              <a:t>DAC unit</a:t>
-            </a:r>
-          </a:p>
-        </p:txBody>
-      </p:sp>
-      <p:sp>
-        <p:nvSpPr>
-          <p:cNvPr id="10" name="Rounded Rectangle 9"/>
+              <a:t>full battery access</a:t>
+            </a:r>
+          </a:p>
+        </p:txBody>
+      </p:sp>
+      <p:sp>
+        <p:nvSpPr>
+          <p:cNvPr id="12" name="Down Arrow 11"/>
           <p:cNvSpPr/>
           <p:nvPr/>
         </p:nvSpPr>
         <p:spPr>
           <a:xfrm>
-            <a:off x="4389120" y="2770631"/>
-            <a:ext cx="1828800" cy="384048"/>
-          </a:xfrm>
-          <a:prstGeom prst="roundRect">
-            <a:avLst>
-              <a:gd name="adj" fmla="val 12000"/>
-            </a:avLst>
+            <a:off x="1513332" y="2487167"/>
+            <a:ext cx="219456" cy="512064"/>
+          </a:xfrm>
+          <a:prstGeom prst="downArrow">
+            <a:avLst/>
           </a:prstGeom>
           <a:solidFill>
-            <a:srgbClr val="FCE4E4"/>
+            <a:srgbClr val="9AA1AC"/>
           </a:solidFill>
           <a:ln>
             <a:noFill/>
@@ -4203,32 +4286,23 @@
           </a:fontRef>
         </p:style>
         <p:txBody>
-          <a:bodyPr rtlCol="0" anchor="ctr" wrap="square" lIns="50800" rIns="50800"/>
+          <a:bodyPr rtlCol="0" anchor="ctr"/>
           <a:lstStyle/>
           <a:p>
             <a:pPr algn="ctr"/>
-            <a:r>
-              <a:rPr sz="1100" b="1">
-                <a:solidFill>
-                  <a:srgbClr val="9A2A2A"/>
-                </a:solidFill>
-                <a:latin typeface="Calibri"/>
-              </a:rPr>
-              <a:t>Sabatier reactor</a:t>
-            </a:r>
-          </a:p>
-        </p:txBody>
-      </p:sp>
-      <p:sp>
-        <p:nvSpPr>
-          <p:cNvPr id="11" name="Rounded Rectangle 10"/>
+          </a:p>
+        </p:txBody>
+      </p:sp>
+      <p:sp>
+        <p:nvSpPr>
+          <p:cNvPr id="13" name="Rounded Rectangle 12"/>
           <p:cNvSpPr/>
           <p:nvPr/>
         </p:nvSpPr>
         <p:spPr>
           <a:xfrm>
-            <a:off x="640080" y="3319271"/>
-            <a:ext cx="5577840" cy="502920"/>
+            <a:off x="640080" y="3886199"/>
+            <a:ext cx="4709160" cy="457200"/>
           </a:xfrm>
           <a:prstGeom prst="roundRect">
             <a:avLst>
@@ -4263,27 +4337,27 @@
           <a:p>
             <a:pPr algn="ctr"/>
             <a:r>
-              <a:rPr sz="1100" b="1">
+              <a:rPr sz="1050" b="1">
                 <a:solidFill>
                   <a:srgbClr val="FFFFFF"/>
                 </a:solidFill>
                 <a:latin typeface="Calibri"/>
               </a:rPr>
-              <a:t>RTU  —  deterministic hard-limit protection layer (SOC bounds, load caps, reserve lock)</a:t>
-            </a:r>
-          </a:p>
-        </p:txBody>
-      </p:sp>
-      <p:sp>
-        <p:nvSpPr>
-          <p:cNvPr id="12" name="TextBox 11"/>
+              <a:t>RTU  —  deterministic hard-limit layer (SOC bounds, load caps, reserve lock)</a:t>
+            </a:r>
+          </a:p>
+        </p:txBody>
+      </p:sp>
+      <p:sp>
+        <p:nvSpPr>
+          <p:cNvPr id="14" name="TextBox 13"/>
           <p:cNvSpPr txBox="1"/>
           <p:nvPr/>
         </p:nvSpPr>
         <p:spPr>
           <a:xfrm>
-            <a:off x="640080" y="3941063"/>
-            <a:ext cx="5577840" cy="640080"/>
+            <a:off x="640080" y="4453127"/>
+            <a:ext cx="4709160" cy="685800"/>
           </a:xfrm>
           <a:prstGeom prst="rect">
             <a:avLst/>
@@ -4305,13 +4379,13 @@
               </a:spcAft>
             </a:pPr>
             <a:r>
-              <a:rPr sz="1100" b="0" i="1">
+              <a:rPr sz="1050" b="0" i="1">
                 <a:solidFill>
                   <a:srgbClr val="5B6372"/>
                 </a:solidFill>
                 <a:latin typeface="Calibri"/>
               </a:rPr>
-              <a:t>Seven strategy modules plug into one shared decide() interface here —</a:t>
+              <a:t>Seven strategy modules plug into one shared decide() interface between the battery and the reactor —</a:t>
             </a:r>
           </a:p>
           <a:p>
@@ -4324,20 +4398,20 @@
               </a:spcAft>
             </a:pPr>
             <a:r>
-              <a:rPr sz="1100" b="0" i="1">
+              <a:rPr sz="1050" b="0" i="1">
                 <a:solidFill>
                   <a:srgbClr val="5B6372"/>
                 </a:solidFill>
                 <a:latin typeface="Calibri"/>
               </a:rPr>
-              <a:t>only the control logic changes between runs.</a:t>
-            </a:r>
-          </a:p>
-        </p:txBody>
-      </p:sp>
-      <p:sp>
-        <p:nvSpPr>
-          <p:cNvPr id="13" name="Rounded Rectangle 12"/>
+              <a:t>only the control logic changes between runs; the electrolyzer/DAC path above is identical for all seven.</a:t>
+            </a:r>
+          </a:p>
+        </p:txBody>
+      </p:sp>
+      <p:sp>
+        <p:nvSpPr>
+          <p:cNvPr id="15" name="Rounded Rectangle 14"/>
           <p:cNvSpPr/>
           <p:nvPr/>
         </p:nvSpPr>
@@ -4383,7 +4457,7 @@
       </p:sp>
       <p:sp>
         <p:nvSpPr>
-          <p:cNvPr id="14" name="TextBox 13"/>
+          <p:cNvPr id="16" name="TextBox 15"/>
           <p:cNvSpPr txBox="1"/>
           <p:nvPr/>
         </p:nvSpPr>
@@ -4425,7 +4499,7 @@
       </p:sp>
       <p:sp>
         <p:nvSpPr>
-          <p:cNvPr id="15" name="TextBox 14"/>
+          <p:cNvPr id="17" name="TextBox 16"/>
           <p:cNvSpPr txBox="1"/>
           <p:nvPr/>
         </p:nvSpPr>
@@ -4532,7 +4606,7 @@
       </p:sp>
       <p:sp>
         <p:nvSpPr>
-          <p:cNvPr id="16" name="TextBox 15"/>
+          <p:cNvPr id="18" name="TextBox 17"/>
           <p:cNvSpPr txBox="1"/>
           <p:nvPr/>
         </p:nvSpPr>

</xml_diff>

<commit_message>
Fix a real arithmetic error: 760 kWh does not exceed 800 kWh
Both the docx, the deck, and the original code comments claimed the
760 kWh single-night need "exceeds" the 800 kWh reserve -- backwards.
The actual point is that it uses up nearly all of it, leaving no
margin for a second night. Also tightened slide 3's decide()-interface
caption for accuracy.

Co-Authored-By: Claude Sonnet 5 <noreply@anthropic.com>
</commit_message>
<xml_diff>
--- a/SOTA_Commission_II_Slides.pptx
+++ b/SOTA_Commission_II_Slides.pptx
@@ -4385,7 +4385,7 @@
                 </a:solidFill>
                 <a:latin typeface="Calibri"/>
               </a:rPr>
-              <a:t>Seven strategy modules plug into one shared decide() interface between the battery and the reactor —</a:t>
+              <a:t>Seven strategy modules plug into one shared decide() interface that sets both paths every hour —</a:t>
             </a:r>
           </a:p>
           <a:p>
@@ -4404,7 +4404,7 @@
                 </a:solidFill>
                 <a:latin typeface="Calibri"/>
               </a:rPr>
-              <a:t>only the control logic changes between runs; the electrolyzer/DAC path above is identical for all seven.</a:t>
+              <a:t>only the control logic changes between runs; the electrolyzer/DAC allocation rule itself is identical for all seven, just switched on or off differently.</a:t>
             </a:r>
           </a:p>
         </p:txBody>
@@ -6408,7 +6408,7 @@
                 </a:solidFill>
                 <a:latin typeface="Calibri"/>
               </a:rPr>
-              <a:t>Cause: a single winter night's reactor-protection need (~760 kWh) already exceeds the largest reserve tested (800 kWh).</a:t>
+              <a:t>Cause: a single winter night's reactor-protection need (~760 kWh) already uses nearly all of the largest reserve tested (800 kWh) — no margin for a second night, let alone a real multi-day deficit.</a:t>
             </a:r>
           </a:p>
           <a:p>

</xml_diff>

<commit_message>
Add a slide explaining how each of the 7 strategies decides
New slide 4 lists each strategy's actual trigger signal in one
sentence each -- what varies behind the shared decide() interface
introduced on the architecture slide, using the same strategy color
key as the results chart and GIF for visual continuity.

Co-Authored-By: Claude Sonnet 5 <noreply@anthropic.com>
</commit_message>
<xml_diff>
--- a/SOTA_Commission_II_Slides.pptx
+++ b/SOTA_Commission_II_Slides.pptx
@@ -12,6 +12,7 @@
     <p:sldId id="260" r:id="rId11"/>
     <p:sldId id="261" r:id="rId12"/>
     <p:sldId id="262" r:id="rId13"/>
+    <p:sldId id="263" r:id="rId14"/>
   </p:sldIdLst>
   <p:sldSz cx="12191695" cy="6858000" type="screen4x3"/>
   <p:notesSz cx="6858000" cy="9144000"/>
@@ -4655,6 +4656,1110 @@
 </file>
 
 <file path=ppt/slides/slide4.xml><?xml version="1.0" encoding="utf-8"?>
+<p:sld xmlns:a="http://schemas.openxmlformats.org/drawingml/2006/main" xmlns:p="http://schemas.openxmlformats.org/presentationml/2006/main" xmlns:r="http://schemas.openxmlformats.org/officeDocument/2006/relationships">
+  <p:cSld>
+    <p:bg>
+      <p:bgPr>
+        <a:solidFill>
+          <a:srgbClr val="FFFFFF"/>
+        </a:solidFill>
+        <a:effectLst/>
+      </p:bgPr>
+    </p:bg>
+    <p:spTree>
+      <p:nvGrpSpPr>
+        <p:cNvPr id="1" name=""/>
+        <p:cNvGrpSpPr/>
+        <p:nvPr/>
+      </p:nvGrpSpPr>
+      <p:grpSpPr/>
+      <p:sp>
+        <p:nvSpPr>
+          <p:cNvPr id="2" name="TextBox 1"/>
+          <p:cNvSpPr txBox="1"/>
+          <p:nvPr/>
+        </p:nvSpPr>
+        <p:spPr>
+          <a:xfrm>
+            <a:off x="640080" y="457200"/>
+            <a:ext cx="5486400" cy="320040"/>
+          </a:xfrm>
+          <a:prstGeom prst="rect">
+            <a:avLst/>
+          </a:prstGeom>
+          <a:noFill/>
+        </p:spPr>
+        <p:txBody>
+          <a:bodyPr wrap="square" anchor="t" lIns="0" rIns="0" tIns="0" bIns="0">
+            <a:spAutoFit/>
+          </a:bodyPr>
+          <a:lstStyle/>
+          <a:p>
+            <a:pPr algn="l">
+              <a:lnSpc>
+                <a:spcPct val="115000"/>
+              </a:lnSpc>
+              <a:spcAft>
+                <a:spcPts val="0"/>
+              </a:spcAft>
+            </a:pPr>
+            <a:r>
+              <a:rPr sz="1200" b="1" i="0">
+                <a:solidFill>
+                  <a:srgbClr val="1E2761"/>
+                </a:solidFill>
+                <a:latin typeface="Calibri"/>
+              </a:rPr>
+              <a:t>THE STRATEGIES</a:t>
+            </a:r>
+          </a:p>
+        </p:txBody>
+      </p:sp>
+      <p:sp>
+        <p:nvSpPr>
+          <p:cNvPr id="3" name="TextBox 2"/>
+          <p:cNvSpPr txBox="1"/>
+          <p:nvPr/>
+        </p:nvSpPr>
+        <p:spPr>
+          <a:xfrm>
+            <a:off x="640080" y="749808"/>
+            <a:ext cx="10881360" cy="777240"/>
+          </a:xfrm>
+          <a:prstGeom prst="rect">
+            <a:avLst/>
+          </a:prstGeom>
+          <a:noFill/>
+        </p:spPr>
+        <p:txBody>
+          <a:bodyPr wrap="square" anchor="t" lIns="0" rIns="0" tIns="0" bIns="0">
+            <a:spAutoFit/>
+          </a:bodyPr>
+          <a:lstStyle/>
+          <a:p>
+            <a:pPr algn="l">
+              <a:lnSpc>
+                <a:spcPct val="115000"/>
+              </a:lnSpc>
+              <a:spcAft>
+                <a:spcPts val="0"/>
+              </a:spcAft>
+            </a:pPr>
+            <a:r>
+              <a:rPr sz="3000" b="1" i="0">
+                <a:solidFill>
+                  <a:srgbClr val="1A1A1A"/>
+                </a:solidFill>
+                <a:latin typeface="Cambria"/>
+              </a:rPr>
+              <a:t>Same switch, seven different triggers</a:t>
+            </a:r>
+          </a:p>
+        </p:txBody>
+      </p:sp>
+      <p:sp>
+        <p:nvSpPr>
+          <p:cNvPr id="4" name="TextBox 3"/>
+          <p:cNvSpPr txBox="1"/>
+          <p:nvPr/>
+        </p:nvSpPr>
+        <p:spPr>
+          <a:xfrm>
+            <a:off x="640080" y="1691640"/>
+            <a:ext cx="10881360" cy="548640"/>
+          </a:xfrm>
+          <a:prstGeom prst="rect">
+            <a:avLst/>
+          </a:prstGeom>
+          <a:noFill/>
+        </p:spPr>
+        <p:txBody>
+          <a:bodyPr wrap="square" anchor="t" lIns="0" rIns="0" tIns="0" bIns="0">
+            <a:spAutoFit/>
+          </a:bodyPr>
+          <a:lstStyle/>
+          <a:p>
+            <a:pPr algn="l">
+              <a:lnSpc>
+                <a:spcPct val="125000"/>
+              </a:lnSpc>
+              <a:spcAft>
+                <a:spcPts val="0"/>
+              </a:spcAft>
+            </a:pPr>
+            <a:r>
+              <a:rPr sz="1350" b="0" i="1">
+                <a:solidFill>
+                  <a:srgbClr val="5B6372"/>
+                </a:solidFill>
+                <a:latin typeface="Calibri"/>
+              </a:rPr>
+              <a:t>Every strategy flips the same switch — whether the electrolyzer/DAC keep drawing PV surplus, or hand all of it to the battery. What changes is only the signal that decides when.</a:t>
+            </a:r>
+          </a:p>
+        </p:txBody>
+      </p:sp>
+      <p:sp>
+        <p:nvSpPr>
+          <p:cNvPr id="5" name="Rounded Rectangle 4"/>
+          <p:cNvSpPr/>
+          <p:nvPr/>
+        </p:nvSpPr>
+        <p:spPr>
+          <a:xfrm>
+            <a:off x="640080" y="2340864"/>
+            <a:ext cx="146304" cy="146304"/>
+          </a:xfrm>
+          <a:prstGeom prst="roundRect">
+            <a:avLst>
+              <a:gd name="adj" fmla="val 50000"/>
+            </a:avLst>
+          </a:prstGeom>
+          <a:solidFill>
+            <a:srgbClr val="94A3B8"/>
+          </a:solidFill>
+          <a:ln>
+            <a:noFill/>
+          </a:ln>
+          <a:effectLst/>
+        </p:spPr>
+        <p:style>
+          <a:lnRef idx="1">
+            <a:schemeClr val="accent1"/>
+          </a:lnRef>
+          <a:fillRef idx="3">
+            <a:schemeClr val="accent1"/>
+          </a:fillRef>
+          <a:effectRef idx="2">
+            <a:schemeClr val="accent1"/>
+          </a:effectRef>
+          <a:fontRef idx="minor">
+            <a:schemeClr val="lt1"/>
+          </a:fontRef>
+        </p:style>
+        <p:txBody>
+          <a:bodyPr rtlCol="0" anchor="ctr"/>
+          <a:lstStyle/>
+          <a:p>
+            <a:pPr algn="ctr"/>
+          </a:p>
+        </p:txBody>
+      </p:sp>
+      <p:sp>
+        <p:nvSpPr>
+          <p:cNvPr id="6" name="TextBox 5"/>
+          <p:cNvSpPr txBox="1"/>
+          <p:nvPr/>
+        </p:nvSpPr>
+        <p:spPr>
+          <a:xfrm>
+            <a:off x="914400" y="2286000"/>
+            <a:ext cx="2468880" cy="585216"/>
+          </a:xfrm>
+          <a:prstGeom prst="rect">
+            <a:avLst/>
+          </a:prstGeom>
+          <a:noFill/>
+        </p:spPr>
+        <p:txBody>
+          <a:bodyPr wrap="square" anchor="t" lIns="0" rIns="0" tIns="0" bIns="0">
+            <a:spAutoFit/>
+          </a:bodyPr>
+          <a:lstStyle/>
+          <a:p>
+            <a:pPr algn="l">
+              <a:lnSpc>
+                <a:spcPct val="115000"/>
+              </a:lnSpc>
+              <a:spcAft>
+                <a:spcPts val="0"/>
+              </a:spcAft>
+            </a:pPr>
+            <a:r>
+              <a:rPr sz="1250" b="1" i="0">
+                <a:solidFill>
+                  <a:srgbClr val="1A1A1A"/>
+                </a:solidFill>
+                <a:latin typeface="Calibri"/>
+              </a:rPr>
+              <a:t>1. Reactive Baseline</a:t>
+            </a:r>
+          </a:p>
+        </p:txBody>
+      </p:sp>
+      <p:sp>
+        <p:nvSpPr>
+          <p:cNvPr id="7" name="TextBox 6"/>
+          <p:cNvSpPr txBox="1"/>
+          <p:nvPr/>
+        </p:nvSpPr>
+        <p:spPr>
+          <a:xfrm>
+            <a:off x="3520440" y="2286000"/>
+            <a:ext cx="8001000" cy="585216"/>
+          </a:xfrm>
+          <a:prstGeom prst="rect">
+            <a:avLst/>
+          </a:prstGeom>
+          <a:noFill/>
+        </p:spPr>
+        <p:txBody>
+          <a:bodyPr wrap="square" anchor="t" lIns="0" rIns="0" tIns="0" bIns="0">
+            <a:spAutoFit/>
+          </a:bodyPr>
+          <a:lstStyle/>
+          <a:p>
+            <a:pPr algn="l">
+              <a:lnSpc>
+                <a:spcPct val="120000"/>
+              </a:lnSpc>
+              <a:spcAft>
+                <a:spcPts val="0"/>
+              </a:spcAft>
+            </a:pPr>
+            <a:r>
+              <a:rPr sz="1150" b="0" i="0">
+                <a:solidFill>
+                  <a:srgbClr val="5B6372"/>
+                </a:solidFill>
+                <a:latin typeface="Calibri"/>
+              </a:rPr>
+              <a:t>No forecast, no reserve — electrolyzer and DAC are never proactively switched off. The reference point the other six are compared against.</a:t>
+            </a:r>
+          </a:p>
+        </p:txBody>
+      </p:sp>
+      <p:sp>
+        <p:nvSpPr>
+          <p:cNvPr id="8" name="Rounded Rectangle 7"/>
+          <p:cNvSpPr/>
+          <p:nvPr/>
+        </p:nvSpPr>
+        <p:spPr>
+          <a:xfrm>
+            <a:off x="640080" y="2926080"/>
+            <a:ext cx="146304" cy="146304"/>
+          </a:xfrm>
+          <a:prstGeom prst="roundRect">
+            <a:avLst>
+              <a:gd name="adj" fmla="val 50000"/>
+            </a:avLst>
+          </a:prstGeom>
+          <a:solidFill>
+            <a:srgbClr val="60A5FA"/>
+          </a:solidFill>
+          <a:ln>
+            <a:noFill/>
+          </a:ln>
+          <a:effectLst/>
+        </p:spPr>
+        <p:style>
+          <a:lnRef idx="1">
+            <a:schemeClr val="accent1"/>
+          </a:lnRef>
+          <a:fillRef idx="3">
+            <a:schemeClr val="accent1"/>
+          </a:fillRef>
+          <a:effectRef idx="2">
+            <a:schemeClr val="accent1"/>
+          </a:effectRef>
+          <a:fontRef idx="minor">
+            <a:schemeClr val="lt1"/>
+          </a:fontRef>
+        </p:style>
+        <p:txBody>
+          <a:bodyPr rtlCol="0" anchor="ctr"/>
+          <a:lstStyle/>
+          <a:p>
+            <a:pPr algn="ctr"/>
+          </a:p>
+        </p:txBody>
+      </p:sp>
+      <p:sp>
+        <p:nvSpPr>
+          <p:cNvPr id="9" name="TextBox 8"/>
+          <p:cNvSpPr txBox="1"/>
+          <p:nvPr/>
+        </p:nvSpPr>
+        <p:spPr>
+          <a:xfrm>
+            <a:off x="914400" y="2871216"/>
+            <a:ext cx="2468880" cy="585216"/>
+          </a:xfrm>
+          <a:prstGeom prst="rect">
+            <a:avLst/>
+          </a:prstGeom>
+          <a:noFill/>
+        </p:spPr>
+        <p:txBody>
+          <a:bodyPr wrap="square" anchor="t" lIns="0" rIns="0" tIns="0" bIns="0">
+            <a:spAutoFit/>
+          </a:bodyPr>
+          <a:lstStyle/>
+          <a:p>
+            <a:pPr algn="l">
+              <a:lnSpc>
+                <a:spcPct val="115000"/>
+              </a:lnSpc>
+              <a:spcAft>
+                <a:spcPts val="0"/>
+              </a:spcAft>
+            </a:pPr>
+            <a:r>
+              <a:rPr sz="1250" b="1" i="0">
+                <a:solidFill>
+                  <a:srgbClr val="1A1A1A"/>
+                </a:solidFill>
+                <a:latin typeface="Calibri"/>
+              </a:rPr>
+              <a:t>2. Fixed Reserve</a:t>
+            </a:r>
+          </a:p>
+        </p:txBody>
+      </p:sp>
+      <p:sp>
+        <p:nvSpPr>
+          <p:cNvPr id="10" name="TextBox 9"/>
+          <p:cNvSpPr txBox="1"/>
+          <p:nvPr/>
+        </p:nvSpPr>
+        <p:spPr>
+          <a:xfrm>
+            <a:off x="3520440" y="2871216"/>
+            <a:ext cx="8001000" cy="585216"/>
+          </a:xfrm>
+          <a:prstGeom prst="rect">
+            <a:avLst/>
+          </a:prstGeom>
+          <a:noFill/>
+        </p:spPr>
+        <p:txBody>
+          <a:bodyPr wrap="square" anchor="t" lIns="0" rIns="0" tIns="0" bIns="0">
+            <a:spAutoFit/>
+          </a:bodyPr>
+          <a:lstStyle/>
+          <a:p>
+            <a:pPr algn="l">
+              <a:lnSpc>
+                <a:spcPct val="120000"/>
+              </a:lnSpc>
+              <a:spcAft>
+                <a:spcPts val="0"/>
+              </a:spcAft>
+            </a:pPr>
+            <a:r>
+              <a:rPr sz="1150" b="0" i="0">
+                <a:solidFill>
+                  <a:srgbClr val="5B6372"/>
+                </a:solidFill>
+                <a:latin typeface="Calibri"/>
+              </a:rPr>
+              <a:t>No forecast: switches off whenever the battery's own charge drops below a fixed threshold, regardless of tomorrow's weather.</a:t>
+            </a:r>
+          </a:p>
+        </p:txBody>
+      </p:sp>
+      <p:sp>
+        <p:nvSpPr>
+          <p:cNvPr id="11" name="Rounded Rectangle 10"/>
+          <p:cNvSpPr/>
+          <p:nvPr/>
+        </p:nvSpPr>
+        <p:spPr>
+          <a:xfrm>
+            <a:off x="640080" y="3511296"/>
+            <a:ext cx="146304" cy="146304"/>
+          </a:xfrm>
+          <a:prstGeom prst="roundRect">
+            <a:avLst>
+              <a:gd name="adj" fmla="val 50000"/>
+            </a:avLst>
+          </a:prstGeom>
+          <a:solidFill>
+            <a:srgbClr val="34D399"/>
+          </a:solidFill>
+          <a:ln>
+            <a:noFill/>
+          </a:ln>
+          <a:effectLst/>
+        </p:spPr>
+        <p:style>
+          <a:lnRef idx="1">
+            <a:schemeClr val="accent1"/>
+          </a:lnRef>
+          <a:fillRef idx="3">
+            <a:schemeClr val="accent1"/>
+          </a:fillRef>
+          <a:effectRef idx="2">
+            <a:schemeClr val="accent1"/>
+          </a:effectRef>
+          <a:fontRef idx="minor">
+            <a:schemeClr val="lt1"/>
+          </a:fontRef>
+        </p:style>
+        <p:txBody>
+          <a:bodyPr rtlCol="0" anchor="ctr"/>
+          <a:lstStyle/>
+          <a:p>
+            <a:pPr algn="ctr"/>
+          </a:p>
+        </p:txBody>
+      </p:sp>
+      <p:sp>
+        <p:nvSpPr>
+          <p:cNvPr id="12" name="TextBox 11"/>
+          <p:cNvSpPr txBox="1"/>
+          <p:nvPr/>
+        </p:nvSpPr>
+        <p:spPr>
+          <a:xfrm>
+            <a:off x="914400" y="3456432"/>
+            <a:ext cx="2468880" cy="585216"/>
+          </a:xfrm>
+          <a:prstGeom prst="rect">
+            <a:avLst/>
+          </a:prstGeom>
+          <a:noFill/>
+        </p:spPr>
+        <p:txBody>
+          <a:bodyPr wrap="square" anchor="t" lIns="0" rIns="0" tIns="0" bIns="0">
+            <a:spAutoFit/>
+          </a:bodyPr>
+          <a:lstStyle/>
+          <a:p>
+            <a:pPr algn="l">
+              <a:lnSpc>
+                <a:spcPct val="115000"/>
+              </a:lnSpc>
+              <a:spcAft>
+                <a:spcPts val="0"/>
+              </a:spcAft>
+            </a:pPr>
+            <a:r>
+              <a:rPr sz="1250" b="1" i="0">
+                <a:solidFill>
+                  <a:srgbClr val="1A1A1A"/>
+                </a:solidFill>
+                <a:latin typeface="Calibri"/>
+              </a:rPr>
+              <a:t>3. Forecast Binary</a:t>
+            </a:r>
+          </a:p>
+        </p:txBody>
+      </p:sp>
+      <p:sp>
+        <p:nvSpPr>
+          <p:cNvPr id="13" name="TextBox 12"/>
+          <p:cNvSpPr txBox="1"/>
+          <p:nvPr/>
+        </p:nvSpPr>
+        <p:spPr>
+          <a:xfrm>
+            <a:off x="3520440" y="3456432"/>
+            <a:ext cx="8001000" cy="585216"/>
+          </a:xfrm>
+          <a:prstGeom prst="rect">
+            <a:avLst/>
+          </a:prstGeom>
+          <a:noFill/>
+        </p:spPr>
+        <p:txBody>
+          <a:bodyPr wrap="square" anchor="t" lIns="0" rIns="0" tIns="0" bIns="0">
+            <a:spAutoFit/>
+          </a:bodyPr>
+          <a:lstStyle/>
+          <a:p>
+            <a:pPr algn="l">
+              <a:lnSpc>
+                <a:spcPct val="120000"/>
+              </a:lnSpc>
+              <a:spcAft>
+                <a:spcPts val="0"/>
+              </a:spcAft>
+            </a:pPr>
+            <a:r>
+              <a:rPr sz="1150" b="0" i="0">
+                <a:solidFill>
+                  <a:srgbClr val="5B6372"/>
+                </a:solidFill>
+                <a:latin typeface="Calibri"/>
+              </a:rPr>
+              <a:t>Sums the forecast window into one deficit number; if it's short, switches off with a fixed-size reserve.</a:t>
+            </a:r>
+          </a:p>
+        </p:txBody>
+      </p:sp>
+      <p:sp>
+        <p:nvSpPr>
+          <p:cNvPr id="14" name="Rounded Rectangle 13"/>
+          <p:cNvSpPr/>
+          <p:nvPr/>
+        </p:nvSpPr>
+        <p:spPr>
+          <a:xfrm>
+            <a:off x="640080" y="4096512"/>
+            <a:ext cx="146304" cy="146304"/>
+          </a:xfrm>
+          <a:prstGeom prst="roundRect">
+            <a:avLst>
+              <a:gd name="adj" fmla="val 50000"/>
+            </a:avLst>
+          </a:prstGeom>
+          <a:solidFill>
+            <a:srgbClr val="FBBF24"/>
+          </a:solidFill>
+          <a:ln>
+            <a:noFill/>
+          </a:ln>
+          <a:effectLst/>
+        </p:spPr>
+        <p:style>
+          <a:lnRef idx="1">
+            <a:schemeClr val="accent1"/>
+          </a:lnRef>
+          <a:fillRef idx="3">
+            <a:schemeClr val="accent1"/>
+          </a:fillRef>
+          <a:effectRef idx="2">
+            <a:schemeClr val="accent1"/>
+          </a:effectRef>
+          <a:fontRef idx="minor">
+            <a:schemeClr val="lt1"/>
+          </a:fontRef>
+        </p:style>
+        <p:txBody>
+          <a:bodyPr rtlCol="0" anchor="ctr"/>
+          <a:lstStyle/>
+          <a:p>
+            <a:pPr algn="ctr"/>
+          </a:p>
+        </p:txBody>
+      </p:sp>
+      <p:sp>
+        <p:nvSpPr>
+          <p:cNvPr id="15" name="TextBox 14"/>
+          <p:cNvSpPr txBox="1"/>
+          <p:nvPr/>
+        </p:nvSpPr>
+        <p:spPr>
+          <a:xfrm>
+            <a:off x="914400" y="4041648"/>
+            <a:ext cx="2468880" cy="585216"/>
+          </a:xfrm>
+          <a:prstGeom prst="rect">
+            <a:avLst/>
+          </a:prstGeom>
+          <a:noFill/>
+        </p:spPr>
+        <p:txBody>
+          <a:bodyPr wrap="square" anchor="t" lIns="0" rIns="0" tIns="0" bIns="0">
+            <a:spAutoFit/>
+          </a:bodyPr>
+          <a:lstStyle/>
+          <a:p>
+            <a:pPr algn="l">
+              <a:lnSpc>
+                <a:spcPct val="115000"/>
+              </a:lnSpc>
+              <a:spcAft>
+                <a:spcPts val="0"/>
+              </a:spcAft>
+            </a:pPr>
+            <a:r>
+              <a:rPr sz="1250" b="1" i="0">
+                <a:solidFill>
+                  <a:srgbClr val="1A1A1A"/>
+                </a:solidFill>
+                <a:latin typeface="Calibri"/>
+              </a:rPr>
+              <a:t>4. Proportional Reserve</a:t>
+            </a:r>
+          </a:p>
+        </p:txBody>
+      </p:sp>
+      <p:sp>
+        <p:nvSpPr>
+          <p:cNvPr id="16" name="TextBox 15"/>
+          <p:cNvSpPr txBox="1"/>
+          <p:nvPr/>
+        </p:nvSpPr>
+        <p:spPr>
+          <a:xfrm>
+            <a:off x="3520440" y="4041648"/>
+            <a:ext cx="8001000" cy="585216"/>
+          </a:xfrm>
+          <a:prstGeom prst="rect">
+            <a:avLst/>
+          </a:prstGeom>
+          <a:noFill/>
+        </p:spPr>
+        <p:txBody>
+          <a:bodyPr wrap="square" anchor="t" lIns="0" rIns="0" tIns="0" bIns="0">
+            <a:spAutoFit/>
+          </a:bodyPr>
+          <a:lstStyle/>
+          <a:p>
+            <a:pPr algn="l">
+              <a:lnSpc>
+                <a:spcPct val="120000"/>
+              </a:lnSpc>
+              <a:spcAft>
+                <a:spcPts val="0"/>
+              </a:spcAft>
+            </a:pPr>
+            <a:r>
+              <a:rPr sz="1150" b="0" i="0">
+                <a:solidFill>
+                  <a:srgbClr val="5B6372"/>
+                </a:solidFill>
+                <a:latin typeface="Calibri"/>
+              </a:rPr>
+              <a:t>Same deficit signal as Forecast Binary, but scales the reserve to how severe it is, then projects the battery's trajectory with that margin.</a:t>
+            </a:r>
+          </a:p>
+        </p:txBody>
+      </p:sp>
+      <p:sp>
+        <p:nvSpPr>
+          <p:cNvPr id="17" name="Rounded Rectangle 16"/>
+          <p:cNvSpPr/>
+          <p:nvPr/>
+        </p:nvSpPr>
+        <p:spPr>
+          <a:xfrm>
+            <a:off x="640080" y="4681728"/>
+            <a:ext cx="146304" cy="146304"/>
+          </a:xfrm>
+          <a:prstGeom prst="roundRect">
+            <a:avLst>
+              <a:gd name="adj" fmla="val 50000"/>
+            </a:avLst>
+          </a:prstGeom>
+          <a:solidFill>
+            <a:srgbClr val="F97316"/>
+          </a:solidFill>
+          <a:ln>
+            <a:noFill/>
+          </a:ln>
+          <a:effectLst/>
+        </p:spPr>
+        <p:style>
+          <a:lnRef idx="1">
+            <a:schemeClr val="accent1"/>
+          </a:lnRef>
+          <a:fillRef idx="3">
+            <a:schemeClr val="accent1"/>
+          </a:fillRef>
+          <a:effectRef idx="2">
+            <a:schemeClr val="accent1"/>
+          </a:effectRef>
+          <a:fontRef idx="minor">
+            <a:schemeClr val="lt1"/>
+          </a:fontRef>
+        </p:style>
+        <p:txBody>
+          <a:bodyPr rtlCol="0" anchor="ctr"/>
+          <a:lstStyle/>
+          <a:p>
+            <a:pPr algn="ctr"/>
+          </a:p>
+        </p:txBody>
+      </p:sp>
+      <p:sp>
+        <p:nvSpPr>
+          <p:cNvPr id="18" name="TextBox 17"/>
+          <p:cNvSpPr txBox="1"/>
+          <p:nvPr/>
+        </p:nvSpPr>
+        <p:spPr>
+          <a:xfrm>
+            <a:off x="914400" y="4626864"/>
+            <a:ext cx="2468880" cy="585216"/>
+          </a:xfrm>
+          <a:prstGeom prst="rect">
+            <a:avLst/>
+          </a:prstGeom>
+          <a:noFill/>
+        </p:spPr>
+        <p:txBody>
+          <a:bodyPr wrap="square" anchor="t" lIns="0" rIns="0" tIns="0" bIns="0">
+            <a:spAutoFit/>
+          </a:bodyPr>
+          <a:lstStyle/>
+          <a:p>
+            <a:pPr algn="l">
+              <a:lnSpc>
+                <a:spcPct val="115000"/>
+              </a:lnSpc>
+              <a:spcAft>
+                <a:spcPts val="0"/>
+              </a:spcAft>
+            </a:pPr>
+            <a:r>
+              <a:rPr sz="1250" b="1" i="0">
+                <a:solidFill>
+                  <a:srgbClr val="1A1A1A"/>
+                </a:solidFill>
+                <a:latin typeface="Calibri"/>
+              </a:rPr>
+              <a:t>5. Temperature-Based</a:t>
+            </a:r>
+          </a:p>
+        </p:txBody>
+      </p:sp>
+      <p:sp>
+        <p:nvSpPr>
+          <p:cNvPr id="19" name="TextBox 18"/>
+          <p:cNvSpPr txBox="1"/>
+          <p:nvPr/>
+        </p:nvSpPr>
+        <p:spPr>
+          <a:xfrm>
+            <a:off x="3520440" y="4626864"/>
+            <a:ext cx="8001000" cy="585216"/>
+          </a:xfrm>
+          <a:prstGeom prst="rect">
+            <a:avLst/>
+          </a:prstGeom>
+          <a:noFill/>
+        </p:spPr>
+        <p:txBody>
+          <a:bodyPr wrap="square" anchor="t" lIns="0" rIns="0" tIns="0" bIns="0">
+            <a:spAutoFit/>
+          </a:bodyPr>
+          <a:lstStyle/>
+          <a:p>
+            <a:pPr algn="l">
+              <a:lnSpc>
+                <a:spcPct val="120000"/>
+              </a:lnSpc>
+              <a:spcAft>
+                <a:spcPts val="0"/>
+              </a:spcAft>
+            </a:pPr>
+            <a:r>
+              <a:rPr sz="1150" b="0" i="0">
+                <a:solidFill>
+                  <a:srgbClr val="5B6372"/>
+                </a:solidFill>
+                <a:latin typeface="Calibri"/>
+              </a:rPr>
+              <a:t>Sizes the reserve from Newton's law of cooling: a hot reactor has more free cooling time, so it needs less protection than a cold one.</a:t>
+            </a:r>
+          </a:p>
+        </p:txBody>
+      </p:sp>
+      <p:sp>
+        <p:nvSpPr>
+          <p:cNvPr id="20" name="Rounded Rectangle 19"/>
+          <p:cNvSpPr/>
+          <p:nvPr/>
+        </p:nvSpPr>
+        <p:spPr>
+          <a:xfrm>
+            <a:off x="640080" y="5266944"/>
+            <a:ext cx="146304" cy="146304"/>
+          </a:xfrm>
+          <a:prstGeom prst="roundRect">
+            <a:avLst>
+              <a:gd name="adj" fmla="val 50000"/>
+            </a:avLst>
+          </a:prstGeom>
+          <a:solidFill>
+            <a:srgbClr val="EF4444"/>
+          </a:solidFill>
+          <a:ln>
+            <a:noFill/>
+          </a:ln>
+          <a:effectLst/>
+        </p:spPr>
+        <p:style>
+          <a:lnRef idx="1">
+            <a:schemeClr val="accent1"/>
+          </a:lnRef>
+          <a:fillRef idx="3">
+            <a:schemeClr val="accent1"/>
+          </a:fillRef>
+          <a:effectRef idx="2">
+            <a:schemeClr val="accent1"/>
+          </a:effectRef>
+          <a:fontRef idx="minor">
+            <a:schemeClr val="lt1"/>
+          </a:fontRef>
+        </p:style>
+        <p:txBody>
+          <a:bodyPr rtlCol="0" anchor="ctr"/>
+          <a:lstStyle/>
+          <a:p>
+            <a:pPr algn="ctr"/>
+          </a:p>
+        </p:txBody>
+      </p:sp>
+      <p:sp>
+        <p:nvSpPr>
+          <p:cNvPr id="21" name="TextBox 20"/>
+          <p:cNvSpPr txBox="1"/>
+          <p:nvPr/>
+        </p:nvSpPr>
+        <p:spPr>
+          <a:xfrm>
+            <a:off x="914400" y="5212080"/>
+            <a:ext cx="2468880" cy="585216"/>
+          </a:xfrm>
+          <a:prstGeom prst="rect">
+            <a:avLst/>
+          </a:prstGeom>
+          <a:noFill/>
+        </p:spPr>
+        <p:txBody>
+          <a:bodyPr wrap="square" anchor="t" lIns="0" rIns="0" tIns="0" bIns="0">
+            <a:spAutoFit/>
+          </a:bodyPr>
+          <a:lstStyle/>
+          <a:p>
+            <a:pPr algn="l">
+              <a:lnSpc>
+                <a:spcPct val="115000"/>
+              </a:lnSpc>
+              <a:spcAft>
+                <a:spcPts val="0"/>
+              </a:spcAft>
+            </a:pPr>
+            <a:r>
+              <a:rPr sz="1250" b="1" i="0">
+                <a:solidFill>
+                  <a:srgbClr val="1A1A1A"/>
+                </a:solidFill>
+                <a:latin typeface="Calibri"/>
+              </a:rPr>
+              <a:t>6. Precharge</a:t>
+            </a:r>
+          </a:p>
+        </p:txBody>
+      </p:sp>
+      <p:sp>
+        <p:nvSpPr>
+          <p:cNvPr id="22" name="TextBox 21"/>
+          <p:cNvSpPr txBox="1"/>
+          <p:nvPr/>
+        </p:nvSpPr>
+        <p:spPr>
+          <a:xfrm>
+            <a:off x="3520440" y="5212080"/>
+            <a:ext cx="8001000" cy="585216"/>
+          </a:xfrm>
+          <a:prstGeom prst="rect">
+            <a:avLst/>
+          </a:prstGeom>
+          <a:noFill/>
+        </p:spPr>
+        <p:txBody>
+          <a:bodyPr wrap="square" anchor="t" lIns="0" rIns="0" tIns="0" bIns="0">
+            <a:spAutoFit/>
+          </a:bodyPr>
+          <a:lstStyle/>
+          <a:p>
+            <a:pPr algn="l">
+              <a:lnSpc>
+                <a:spcPct val="120000"/>
+              </a:lnSpc>
+              <a:spcAft>
+                <a:spcPts val="0"/>
+              </a:spcAft>
+            </a:pPr>
+            <a:r>
+              <a:rPr sz="1150" b="0" i="0">
+                <a:solidFill>
+                  <a:srgbClr val="5B6372"/>
+                </a:solidFill>
+                <a:latin typeface="Calibri"/>
+              </a:rPr>
+              <a:t>Switches off earliest, whenever the forecast's average PV output falls below a fixed fraction of capacity — before any deficit is even computable.</a:t>
+            </a:r>
+          </a:p>
+        </p:txBody>
+      </p:sp>
+      <p:sp>
+        <p:nvSpPr>
+          <p:cNvPr id="23" name="Rounded Rectangle 22"/>
+          <p:cNvSpPr/>
+          <p:nvPr/>
+        </p:nvSpPr>
+        <p:spPr>
+          <a:xfrm>
+            <a:off x="640080" y="5852160"/>
+            <a:ext cx="146304" cy="146304"/>
+          </a:xfrm>
+          <a:prstGeom prst="roundRect">
+            <a:avLst>
+              <a:gd name="adj" fmla="val 50000"/>
+            </a:avLst>
+          </a:prstGeom>
+          <a:solidFill>
+            <a:srgbClr val="7C3AED"/>
+          </a:solidFill>
+          <a:ln>
+            <a:noFill/>
+          </a:ln>
+          <a:effectLst/>
+        </p:spPr>
+        <p:style>
+          <a:lnRef idx="1">
+            <a:schemeClr val="accent1"/>
+          </a:lnRef>
+          <a:fillRef idx="3">
+            <a:schemeClr val="accent1"/>
+          </a:fillRef>
+          <a:effectRef idx="2">
+            <a:schemeClr val="accent1"/>
+          </a:effectRef>
+          <a:fontRef idx="minor">
+            <a:schemeClr val="lt1"/>
+          </a:fontRef>
+        </p:style>
+        <p:txBody>
+          <a:bodyPr rtlCol="0" anchor="ctr"/>
+          <a:lstStyle/>
+          <a:p>
+            <a:pPr algn="ctr"/>
+          </a:p>
+        </p:txBody>
+      </p:sp>
+      <p:sp>
+        <p:nvSpPr>
+          <p:cNvPr id="24" name="TextBox 23"/>
+          <p:cNvSpPr txBox="1"/>
+          <p:nvPr/>
+        </p:nvSpPr>
+        <p:spPr>
+          <a:xfrm>
+            <a:off x="914400" y="5797296"/>
+            <a:ext cx="2468880" cy="585216"/>
+          </a:xfrm>
+          <a:prstGeom prst="rect">
+            <a:avLst/>
+          </a:prstGeom>
+          <a:noFill/>
+        </p:spPr>
+        <p:txBody>
+          <a:bodyPr wrap="square" anchor="t" lIns="0" rIns="0" tIns="0" bIns="0">
+            <a:spAutoFit/>
+          </a:bodyPr>
+          <a:lstStyle/>
+          <a:p>
+            <a:pPr algn="l">
+              <a:lnSpc>
+                <a:spcPct val="115000"/>
+              </a:lnSpc>
+              <a:spcAft>
+                <a:spcPts val="0"/>
+              </a:spcAft>
+            </a:pPr>
+            <a:r>
+              <a:rPr sz="1250" b="1" i="0">
+                <a:solidFill>
+                  <a:srgbClr val="1A1A1A"/>
+                </a:solidFill>
+                <a:latin typeface="Calibri"/>
+              </a:rPr>
+              <a:t>7. Rolling Horizon</a:t>
+            </a:r>
+          </a:p>
+        </p:txBody>
+      </p:sp>
+      <p:sp>
+        <p:nvSpPr>
+          <p:cNvPr id="25" name="TextBox 24"/>
+          <p:cNvSpPr txBox="1"/>
+          <p:nvPr/>
+        </p:nvSpPr>
+        <p:spPr>
+          <a:xfrm>
+            <a:off x="3520440" y="5797296"/>
+            <a:ext cx="8001000" cy="585216"/>
+          </a:xfrm>
+          <a:prstGeom prst="rect">
+            <a:avLst/>
+          </a:prstGeom>
+          <a:noFill/>
+        </p:spPr>
+        <p:txBody>
+          <a:bodyPr wrap="square" anchor="t" lIns="0" rIns="0" tIns="0" bIns="0">
+            <a:spAutoFit/>
+          </a:bodyPr>
+          <a:lstStyle/>
+          <a:p>
+            <a:pPr algn="l">
+              <a:lnSpc>
+                <a:spcPct val="120000"/>
+              </a:lnSpc>
+              <a:spcAft>
+                <a:spcPts val="0"/>
+              </a:spcAft>
+            </a:pPr>
+            <a:r>
+              <a:rPr sz="1150" b="0" i="0">
+                <a:solidFill>
+                  <a:srgbClr val="5B6372"/>
+                </a:solidFill>
+                <a:latin typeface="Calibri"/>
+              </a:rPr>
+              <a:t>Projects the battery's charge hour-by-hour across the whole forecast window and reacts to its lowest point, not just the total.</a:t>
+            </a:r>
+          </a:p>
+        </p:txBody>
+      </p:sp>
+      <p:sp>
+        <p:nvSpPr>
+          <p:cNvPr id="26" name="TextBox 25"/>
+          <p:cNvSpPr txBox="1"/>
+          <p:nvPr/>
+        </p:nvSpPr>
+        <p:spPr>
+          <a:xfrm>
+            <a:off x="11551615" y="6400800"/>
+            <a:ext cx="457200" cy="274320"/>
+          </a:xfrm>
+          <a:prstGeom prst="rect">
+            <a:avLst/>
+          </a:prstGeom>
+          <a:noFill/>
+        </p:spPr>
+        <p:txBody>
+          <a:bodyPr wrap="square" anchor="t" lIns="0" rIns="0" tIns="0" bIns="0">
+            <a:spAutoFit/>
+          </a:bodyPr>
+          <a:lstStyle/>
+          <a:p>
+            <a:pPr algn="r">
+              <a:lnSpc>
+                <a:spcPct val="115000"/>
+              </a:lnSpc>
+              <a:spcAft>
+                <a:spcPts val="0"/>
+              </a:spcAft>
+            </a:pPr>
+            <a:r>
+              <a:rPr sz="1000" b="0" i="0">
+                <a:solidFill>
+                  <a:srgbClr val="9AA1AC"/>
+                </a:solidFill>
+                <a:latin typeface="Calibri"/>
+              </a:rPr>
+              <a:t>4</a:t>
+            </a:r>
+          </a:p>
+        </p:txBody>
+      </p:sp>
+    </p:spTree>
+  </p:cSld>
+  <p:clrMapOvr>
+    <a:masterClrMapping/>
+  </p:clrMapOvr>
+</p:sld>
+</file>
+
+<file path=ppt/slides/slide5.xml><?xml version="1.0" encoding="utf-8"?>
 <p:sld xmlns:a="http://schemas.openxmlformats.org/drawingml/2006/main" xmlns:p="http://schemas.openxmlformats.org/presentationml/2006/main" xmlns:r="http://schemas.openxmlformats.org/officeDocument/2006/relationships">
   <p:cSld>
     <p:bg>
@@ -5824,7 +6929,7 @@
                 </a:solidFill>
                 <a:latin typeface="Calibri"/>
               </a:rPr>
-              <a:t>4</a:t>
+              <a:t>5</a:t>
             </a:r>
           </a:p>
         </p:txBody>
@@ -5837,7 +6942,7 @@
 </p:sld>
 </file>
 
-<file path=ppt/slides/slide5.xml><?xml version="1.0" encoding="utf-8"?>
+<file path=ppt/slides/slide6.xml><?xml version="1.0" encoding="utf-8"?>
 <p:sld xmlns:a="http://schemas.openxmlformats.org/drawingml/2006/main" xmlns:p="http://schemas.openxmlformats.org/presentationml/2006/main" xmlns:r="http://schemas.openxmlformats.org/officeDocument/2006/relationships">
   <p:cSld>
     <p:bg>
@@ -6042,7 +7147,7 @@
                 </a:solidFill>
                 <a:latin typeface="Calibri"/>
               </a:rPr>
-              <a:t>5</a:t>
+              <a:t>6</a:t>
             </a:r>
           </a:p>
         </p:txBody>
@@ -6055,7 +7160,7 @@
 </p:sld>
 </file>
 
-<file path=ppt/slides/slide6.xml><?xml version="1.0" encoding="utf-8"?>
+<file path=ppt/slides/slide7.xml><?xml version="1.0" encoding="utf-8"?>
 <p:sld xmlns:a="http://schemas.openxmlformats.org/drawingml/2006/main" xmlns:p="http://schemas.openxmlformats.org/presentationml/2006/main" xmlns:r="http://schemas.openxmlformats.org/officeDocument/2006/relationships">
   <p:cSld>
     <p:bg>
@@ -6492,7 +7597,7 @@
                 </a:solidFill>
                 <a:latin typeface="Calibri"/>
               </a:rPr>
-              <a:t>6</a:t>
+              <a:t>7</a:t>
             </a:r>
           </a:p>
         </p:txBody>
@@ -6505,7 +7610,7 @@
 </p:sld>
 </file>
 
-<file path=ppt/slides/slide7.xml><?xml version="1.0" encoding="utf-8"?>
+<file path=ppt/slides/slide8.xml><?xml version="1.0" encoding="utf-8"?>
 <p:sld xmlns:a="http://schemas.openxmlformats.org/drawingml/2006/main" xmlns:p="http://schemas.openxmlformats.org/presentationml/2006/main" xmlns:r="http://schemas.openxmlformats.org/officeDocument/2006/relationships">
   <p:cSld>
     <p:bg>
@@ -6841,7 +7946,7 @@
                 </a:solidFill>
                 <a:latin typeface="Calibri"/>
               </a:rPr>
-              <a:t>7</a:t>
+              <a:t>8</a:t>
             </a:r>
           </a:p>
         </p:txBody>

</xml_diff>

<commit_message>
Name the electrolyzer/DAC explicitly in three strategy one-liners
"Switches off whenever..." left its subject implicit, relying on the
reader remembering the slide's intro sentence. Spelled out "switches
the electrolyzer/DAC off" in the Fixed Reserve, Forecast Binary, and
Precharge rows so each line stands on its own.

Co-Authored-By: Claude Sonnet 5 <noreply@anthropic.com>
</commit_message>
<xml_diff>
--- a/SOTA_Commission_II_Slides.pptx
+++ b/SOTA_Commission_II_Slides.pptx
@@ -5054,7 +5054,7 @@
                 </a:solidFill>
                 <a:latin typeface="Calibri"/>
               </a:rPr>
-              <a:t>No forecast: switches off whenever the battery's own charge drops below a fixed threshold, regardless of tomorrow's weather.</a:t>
+              <a:t>No forecast: switches the electrolyzer/DAC off whenever the battery's own charge drops below a fixed threshold, regardless of tomorrow's weather.</a:t>
             </a:r>
           </a:p>
         </p:txBody>
@@ -5184,7 +5184,7 @@
                 </a:solidFill>
                 <a:latin typeface="Calibri"/>
               </a:rPr>
-              <a:t>Sums the forecast window into one deficit number; if it's short, switches off with a fixed-size reserve.</a:t>
+              <a:t>Sums the forecast window into one deficit number; if it's short, switches the electrolyzer/DAC off with a fixed-size reserve.</a:t>
             </a:r>
           </a:p>
         </p:txBody>
@@ -5574,7 +5574,7 @@
                 </a:solidFill>
                 <a:latin typeface="Calibri"/>
               </a:rPr>
-              <a:t>Switches off earliest, whenever the forecast's average PV output falls below a fixed fraction of capacity — before any deficit is even computable.</a:t>
+              <a:t>Switches the electrolyzer/DAC off earliest, whenever the forecast's average PV output falls below a fixed fraction of capacity — before any deficit is even computable.</a:t>
             </a:r>
           </a:p>
         </p:txBody>

</xml_diff>